<commit_message>
Alan adı capagastro.org: canonical, hreflang, og ve JSON-LD adresleri, sitemap, 24 QR kodu, sosyal medya kartlarındaki adres satırı, sevk formu yazdırma notu, kimlik sayfası (web satırı, e-posta imzası), kimlik kiti zip'i ve sunum şablonu (önizlemedeki kaynak satırı dahil), takvim UID'leri, 404 bağlantıları (kök yol); araçların varsayılan adresi. Site arama motorlarına kapalı kalıyor: noindex/nofollow etiketleri yerinde, robots.txt taramayı engellemiyor, Sitemap satırı taslak süresince yorumda. README alan adı ve DNS adımları güncellendi.
Co-Authored-By: Claude Opus 5.5 <noreply@anthropic.com>
Claude-Session: https://claude.ai/code/session_01EFJDQ9AaKjdW6DmPPhenrG
</commit_message>
<xml_diff>
--- a/sablon/capagastro-sunum.pptx
+++ b/sablon/capagastro-sunum.pptx
@@ -783,7 +783,7 @@
           <a:p>
             <a:r>
               <a:rPr lang="en-US" dirty="0"/>
-              <a:t>Şablon kullanımı: gereken slaytı çoğaltıp metni değiştirin; kullanmadığınız örnek slaytları silin. Renkler ve logo dosyaları besimagargun.com/capagastro/kimlik.html adresinde. Yazı tipleri Georgia ve Arial olarak ayarlıdır; Fraunces ve Public Sans kuruluysa Giriş &gt; Değiştir &gt; Yazı Tiplerini Değiştir ile dönüştürün. Kapak zemini img/sunum-kapak.png dosyasıdır.</a:t>
+              <a:t>Şablon kullanımı: gereken slaytı çoğaltıp metni değiştirin; kullanmadığınız örnek slaytları silin. Renkler ve logo dosyaları capagastro.org/kimlik.html adresinde. Yazı tipleri Georgia ve Arial olarak ayarlıdır; Fraunces ve Public Sans kuruluysa Giriş &gt; Değiştir &gt; Yazı Tiplerini Değiştir ile dönüştürün. Kapak zemini img/sunum-kapak.png dosyasıdır.</a:t>
             </a:r>
             <a:endParaRPr lang="en-US" dirty="0"/>
           </a:p>
@@ -4374,7 +4374,7 @@
                 <a:ea typeface="Arial" pitchFamily="34" charset="-122"/>
                 <a:cs typeface="Arial" pitchFamily="34" charset="-120"/>
               </a:rPr>
-              <a:t>Kaynak: PubMed, bilim dalı yayın listesi (besimagargun.com/capagastro/yayinlar.html), Eylül 2026.</a:t>
+              <a:t>Kaynak: PubMed, bilim dalı yayın listesi (capagastro.org/yayinlar.html), Eylül 2026.</a:t>
             </a:r>
             <a:endParaRPr lang="en-US" sz="1000" dirty="0"/>
           </a:p>
@@ -4634,7 +4634,7 @@
                 <a:ea typeface="Arial" pitchFamily="34" charset="-122"/>
                 <a:cs typeface="Arial" pitchFamily="34" charset="-120"/>
               </a:rPr>
-              <a:t>besimagargun.com/capagastro</a:t>
+              <a:t>capagastro.org</a:t>
             </a:r>
             <a:endParaRPr lang="en-US" sz="1600" dirty="0"/>
           </a:p>

</xml_diff>